<commit_message>
Adopt v5.0.0 design direction: white substrate, no uppercase, two-tier buttons
Integrates a Claude Design handoff (white substrate replacing cream, sentence
case everywhere, filled+outline button system used site-wide including the
hero, and a new off-black #15130f as shared non-Agustos identity ink) as a
major version bump per the system's own semver policy for philosophy shifts.

Updates the canonical registry (tokens/design-tokens.json, web.css.tmpl,
brand/brands.json), regenerates every downstream artifact (adapter CSS,
WordPress theme.json, the UI kit, and all non-Agustos brand exports: logos,
favicons, social, office templates, guidelines and datasheet PDFs), and
documents the reasoning and the specific reversals in DESIGN.md and
MEMORY.md. Full test suite (71 tests) and both drift checks pass clean.

Co-Authored-By: Claude Sonnet 5 <noreply@anthropic.com>
</commit_message>
<xml_diff>
--- a/brand/exports/agustos/office/agustos-template.pptx
+++ b/brand/exports/agustos/office/agustos-template.pptx
@@ -1213,7 +1213,7 @@
     <p:bg>
       <p:bgPr>
         <a:solidFill>
-          <a:srgbClr val="FEFCF2"/>
+          <a:srgbClr val="FDF5F5"/>
         </a:solidFill>
       </p:bgPr>
     </p:bg>
@@ -1321,7 +1321,7 @@
             <a:r>
               <a:rPr lang="en-US" sz="5400" b="1" dirty="0">
                 <a:solidFill>
-                  <a:srgbClr val="1A1A1A"/>
+                  <a:srgbClr val="15130F"/>
                 </a:solidFill>
                 <a:latin typeface="Inter Tight" pitchFamily="34" charset="0"/>
                 <a:ea typeface="Inter Tight" pitchFamily="34" charset="-122"/>
@@ -1360,7 +1360,7 @@
             <a:r>
               <a:rPr lang="en-US" sz="2000" dirty="0">
                 <a:solidFill>
-                  <a:srgbClr val="4A4A4A"/>
+                  <a:srgbClr val="403B34"/>
                 </a:solidFill>
                 <a:latin typeface="Inter" pitchFamily="34" charset="0"/>
                 <a:ea typeface="Inter" pitchFamily="34" charset="-122"/>
@@ -1387,11 +1387,11 @@
             <a:avLst/>
           </a:prstGeom>
           <a:solidFill>
-            <a:srgbClr val="E8E3D0"/>
+            <a:srgbClr val="E8E4DA"/>
           </a:solidFill>
           <a:ln w="12700">
             <a:solidFill>
-              <a:srgbClr val="E8E3D0">
+              <a:srgbClr val="E8E4DA">
                 <a:alpha val="0"/>
               </a:srgbClr>
             </a:solidFill>
@@ -1426,7 +1426,7 @@
             <a:r>
               <a:rPr lang="en-US" sz="1200" dirty="0">
                 <a:solidFill>
-                  <a:srgbClr val="8A8A8A"/>
+                  <a:srgbClr val="8A8378"/>
                 </a:solidFill>
                 <a:latin typeface="Inter" pitchFamily="34" charset="0"/>
                 <a:ea typeface="Inter" pitchFamily="34" charset="-122"/>
@@ -1521,7 +1521,7 @@
             <a:r>
               <a:rPr lang="en-US" sz="1200" b="1" dirty="0">
                 <a:solidFill>
-                  <a:srgbClr val="FEFCF2"/>
+                  <a:srgbClr val="FDF5F5"/>
                 </a:solidFill>
                 <a:latin typeface="Inter Tight" pitchFamily="34" charset="0"/>
                 <a:ea typeface="Inter Tight" pitchFamily="34" charset="-122"/>
@@ -1560,7 +1560,7 @@
             <a:r>
               <a:rPr lang="en-US" sz="4400" b="1" dirty="0">
                 <a:solidFill>
-                  <a:srgbClr val="FEFCF2"/>
+                  <a:srgbClr val="FDF5F5"/>
                 </a:solidFill>
                 <a:latin typeface="Inter Tight" pitchFamily="34" charset="0"/>
                 <a:ea typeface="Inter Tight" pitchFamily="34" charset="-122"/>
@@ -1587,11 +1587,11 @@
             <a:avLst/>
           </a:prstGeom>
           <a:solidFill>
-            <a:srgbClr val="FEFCF2"/>
+            <a:srgbClr val="FDF5F5"/>
           </a:solidFill>
           <a:ln w="12700">
             <a:solidFill>
-              <a:srgbClr val="FEFCF2">
+              <a:srgbClr val="FDF5F5">
                 <a:alpha val="0"/>
               </a:srgbClr>
             </a:solidFill>
@@ -1613,7 +1613,7 @@
     <p:bg>
       <p:bgPr>
         <a:solidFill>
-          <a:srgbClr val="FEFCF2"/>
+          <a:srgbClr val="FDF5F5"/>
         </a:solidFill>
       </p:bgPr>
     </p:bg>
@@ -1697,7 +1697,7 @@
             <a:r>
               <a:rPr lang="en-US" sz="3600" b="1" dirty="0">
                 <a:solidFill>
-                  <a:srgbClr val="1A1A1A"/>
+                  <a:srgbClr val="15130F"/>
                 </a:solidFill>
                 <a:latin typeface="Inter Tight" pitchFamily="34" charset="0"/>
                 <a:ea typeface="Inter Tight" pitchFamily="34" charset="-122"/>
@@ -1724,11 +1724,11 @@
             <a:avLst/>
           </a:prstGeom>
           <a:solidFill>
-            <a:srgbClr val="E8E3D0"/>
+            <a:srgbClr val="E8E4DA"/>
           </a:solidFill>
           <a:ln w="12700">
             <a:solidFill>
-              <a:srgbClr val="E8E3D0">
+              <a:srgbClr val="E8E4DA">
                 <a:alpha val="0"/>
               </a:srgbClr>
             </a:solidFill>
@@ -1763,7 +1763,7 @@
             <a:r>
               <a:rPr lang="en-US" sz="3200" b="1" dirty="0">
                 <a:solidFill>
-                  <a:srgbClr val="1A1A1A"/>
+                  <a:srgbClr val="15130F"/>
                 </a:solidFill>
                 <a:latin typeface="Inter Tight" pitchFamily="34" charset="0"/>
                 <a:ea typeface="Inter Tight" pitchFamily="34" charset="-122"/>
@@ -1802,7 +1802,7 @@
             <a:r>
               <a:rPr lang="en-US" sz="2000" dirty="0">
                 <a:solidFill>
-                  <a:srgbClr val="4A4A4A"/>
+                  <a:srgbClr val="403B34"/>
                 </a:solidFill>
                 <a:latin typeface="Inter" pitchFamily="34" charset="0"/>
                 <a:ea typeface="Inter" pitchFamily="34" charset="-122"/>
@@ -1841,7 +1841,7 @@
             <a:r>
               <a:rPr lang="en-US" sz="2000" b="1" dirty="0">
                 <a:solidFill>
-                  <a:srgbClr val="1A1A1A"/>
+                  <a:srgbClr val="15130F"/>
                 </a:solidFill>
                 <a:latin typeface="Inter" pitchFamily="34" charset="0"/>
                 <a:ea typeface="Inter" pitchFamily="34" charset="-122"/>
@@ -1880,7 +1880,7 @@
             <a:r>
               <a:rPr lang="en-US" sz="2000" b="1" dirty="0">
                 <a:solidFill>
-                  <a:srgbClr val="1A1A1A"/>
+                  <a:srgbClr val="15130F"/>
                 </a:solidFill>
                 <a:latin typeface="Inter" pitchFamily="34" charset="0"/>
                 <a:ea typeface="Inter" pitchFamily="34" charset="-122"/>
@@ -1919,7 +1919,7 @@
             <a:r>
               <a:rPr lang="en-US" sz="2000" b="1" dirty="0">
                 <a:solidFill>
-                  <a:srgbClr val="1A1A1A"/>
+                  <a:srgbClr val="15130F"/>
                 </a:solidFill>
                 <a:latin typeface="Inter" pitchFamily="34" charset="0"/>
                 <a:ea typeface="Inter" pitchFamily="34" charset="-122"/>
@@ -2029,7 +2029,7 @@
             <a:r>
               <a:rPr lang="en-US" sz="3600" b="1" dirty="0">
                 <a:solidFill>
-                  <a:srgbClr val="1A1A1A"/>
+                  <a:srgbClr val="15130F"/>
                 </a:solidFill>
                 <a:latin typeface="Inter Tight" pitchFamily="34" charset="0"/>
                 <a:ea typeface="Inter Tight" pitchFamily="34" charset="-122"/>
@@ -2173,11 +2173,11 @@
             <a:avLst/>
           </a:prstGeom>
           <a:solidFill>
-            <a:srgbClr val="E8E8E8"/>
+            <a:srgbClr val="E8E4DA"/>
           </a:solidFill>
           <a:ln w="12700">
             <a:solidFill>
-              <a:srgbClr val="E8E8E8">
+              <a:srgbClr val="E8E4DA">
                 <a:alpha val="0"/>
               </a:srgbClr>
             </a:solidFill>
@@ -2212,7 +2212,7 @@
             <a:r>
               <a:rPr lang="en-US" sz="2000" b="1" dirty="0">
                 <a:solidFill>
-                  <a:srgbClr val="1A1A1A"/>
+                  <a:srgbClr val="15130F"/>
                 </a:solidFill>
                 <a:latin typeface="Inter" pitchFamily="34" charset="0"/>
                 <a:ea typeface="Inter" pitchFamily="34" charset="-122"/>
@@ -2251,7 +2251,7 @@
             <a:r>
               <a:rPr lang="en-US" sz="2000" dirty="0">
                 <a:solidFill>
-                  <a:srgbClr val="1A1A1A"/>
+                  <a:srgbClr val="15130F"/>
                 </a:solidFill>
                 <a:latin typeface="JetBrains Mono" pitchFamily="34" charset="0"/>
                 <a:ea typeface="JetBrains Mono" pitchFamily="34" charset="-122"/>
@@ -2290,7 +2290,7 @@
             <a:r>
               <a:rPr lang="en-US" sz="2000" dirty="0">
                 <a:solidFill>
-                  <a:srgbClr val="1A1A1A"/>
+                  <a:srgbClr val="15130F"/>
                 </a:solidFill>
                 <a:latin typeface="Inter" pitchFamily="34" charset="0"/>
                 <a:ea typeface="Inter" pitchFamily="34" charset="-122"/>
@@ -2317,11 +2317,11 @@
             <a:avLst/>
           </a:prstGeom>
           <a:solidFill>
-            <a:srgbClr val="E8E8E8"/>
+            <a:srgbClr val="E8E4DA"/>
           </a:solidFill>
           <a:ln w="12700">
             <a:solidFill>
-              <a:srgbClr val="E8E8E8">
+              <a:srgbClr val="E8E4DA">
                 <a:alpha val="0"/>
               </a:srgbClr>
             </a:solidFill>
@@ -2356,7 +2356,7 @@
             <a:r>
               <a:rPr lang="en-US" sz="2000" b="1" dirty="0">
                 <a:solidFill>
-                  <a:srgbClr val="1A1A1A"/>
+                  <a:srgbClr val="15130F"/>
                 </a:solidFill>
                 <a:latin typeface="Inter" pitchFamily="34" charset="0"/>
                 <a:ea typeface="Inter" pitchFamily="34" charset="-122"/>
@@ -2395,7 +2395,7 @@
             <a:r>
               <a:rPr lang="en-US" sz="2000" dirty="0">
                 <a:solidFill>
-                  <a:srgbClr val="1A1A1A"/>
+                  <a:srgbClr val="15130F"/>
                 </a:solidFill>
                 <a:latin typeface="JetBrains Mono" pitchFamily="34" charset="0"/>
                 <a:ea typeface="JetBrains Mono" pitchFamily="34" charset="-122"/>
@@ -2434,7 +2434,7 @@
             <a:r>
               <a:rPr lang="en-US" sz="2000" dirty="0">
                 <a:solidFill>
-                  <a:srgbClr val="1A1A1A"/>
+                  <a:srgbClr val="15130F"/>
                 </a:solidFill>
                 <a:latin typeface="Inter" pitchFamily="34" charset="0"/>
                 <a:ea typeface="Inter" pitchFamily="34" charset="-122"/>
@@ -2461,11 +2461,11 @@
             <a:avLst/>
           </a:prstGeom>
           <a:solidFill>
-            <a:srgbClr val="E8E8E8"/>
+            <a:srgbClr val="E8E4DA"/>
           </a:solidFill>
           <a:ln w="12700">
             <a:solidFill>
-              <a:srgbClr val="E8E8E8">
+              <a:srgbClr val="E8E4DA">
                 <a:alpha val="0"/>
               </a:srgbClr>
             </a:solidFill>
@@ -2500,7 +2500,7 @@
             <a:r>
               <a:rPr lang="en-US" sz="2000" b="1" dirty="0">
                 <a:solidFill>
-                  <a:srgbClr val="1A1A1A"/>
+                  <a:srgbClr val="15130F"/>
                 </a:solidFill>
                 <a:latin typeface="Inter" pitchFamily="34" charset="0"/>
                 <a:ea typeface="Inter" pitchFamily="34" charset="-122"/>
@@ -2539,7 +2539,7 @@
             <a:r>
               <a:rPr lang="en-US" sz="2000" dirty="0">
                 <a:solidFill>
-                  <a:srgbClr val="1A1A1A"/>
+                  <a:srgbClr val="15130F"/>
                 </a:solidFill>
                 <a:latin typeface="JetBrains Mono" pitchFamily="34" charset="0"/>
                 <a:ea typeface="JetBrains Mono" pitchFamily="34" charset="-122"/>
@@ -2578,7 +2578,7 @@
             <a:r>
               <a:rPr lang="en-US" sz="2000" dirty="0">
                 <a:solidFill>
-                  <a:srgbClr val="1A1A1A"/>
+                  <a:srgbClr val="15130F"/>
                 </a:solidFill>
                 <a:latin typeface="Inter" pitchFamily="34" charset="0"/>
                 <a:ea typeface="Inter" pitchFamily="34" charset="-122"/>
@@ -2605,11 +2605,11 @@
             <a:avLst/>
           </a:prstGeom>
           <a:solidFill>
-            <a:srgbClr val="E8E8E8"/>
+            <a:srgbClr val="E8E4DA"/>
           </a:solidFill>
           <a:ln w="12700">
             <a:solidFill>
-              <a:srgbClr val="E8E8E8">
+              <a:srgbClr val="E8E4DA">
                 <a:alpha val="0"/>
               </a:srgbClr>
             </a:solidFill>
@@ -2644,7 +2644,7 @@
             <a:r>
               <a:rPr lang="en-US" sz="1200" dirty="0">
                 <a:solidFill>
-                  <a:srgbClr val="8A8A8A"/>
+                  <a:srgbClr val="8A8378"/>
                 </a:solidFill>
                 <a:latin typeface="Inter" pitchFamily="34" charset="0"/>
                 <a:ea typeface="Inter" pitchFamily="34" charset="-122"/>
@@ -2670,7 +2670,7 @@
     <p:bg>
       <p:bgPr>
         <a:solidFill>
-          <a:srgbClr val="FEFCF2"/>
+          <a:srgbClr val="FDF5F5"/>
         </a:solidFill>
       </p:bgPr>
     </p:bg>
@@ -2766,11 +2766,11 @@
             <a:avLst/>
           </a:prstGeom>
           <a:solidFill>
-            <a:srgbClr val="E8E3D0"/>
+            <a:srgbClr val="E8E4DA"/>
           </a:solidFill>
           <a:ln w="12700">
             <a:solidFill>
-              <a:srgbClr val="E8E3D0">
+              <a:srgbClr val="E8E4DA">
                 <a:alpha val="0"/>
               </a:srgbClr>
             </a:solidFill>

</xml_diff>

<commit_message>
Adopt v5.0.0 design direction: white substrate, no uppercase, two-tier buttons (#21)
Integrates a Claude Design handoff (white substrate replacing cream, sentence
case everywhere, filled+outline button system used site-wide including the
hero, and a new off-black #15130f as shared non-Agustos identity ink) as a
major version bump per the system's own semver policy for philosophy shifts.

Updates the canonical registry (tokens/design-tokens.json, web.css.tmpl,
brand/brands.json), regenerates every downstream artifact (adapter CSS,
WordPress theme.json, the UI kit, and all non-Agustos brand exports: logos,
favicons, social, office templates, guidelines and datasheet PDFs), and
documents the reasoning and the specific reversals in DESIGN.md and
MEMORY.md. Full test suite (71 tests) and both drift checks pass clean.

Co-authored-by: Claude Sonnet 5 <noreply@anthropic.com>
</commit_message>
<xml_diff>
--- a/brand/exports/agustos/office/agustos-template.pptx
+++ b/brand/exports/agustos/office/agustos-template.pptx
@@ -1213,7 +1213,7 @@
     <p:bg>
       <p:bgPr>
         <a:solidFill>
-          <a:srgbClr val="FEFCF2"/>
+          <a:srgbClr val="FDF5F5"/>
         </a:solidFill>
       </p:bgPr>
     </p:bg>
@@ -1321,7 +1321,7 @@
             <a:r>
               <a:rPr lang="en-US" sz="5400" b="1" dirty="0">
                 <a:solidFill>
-                  <a:srgbClr val="1A1A1A"/>
+                  <a:srgbClr val="15130F"/>
                 </a:solidFill>
                 <a:latin typeface="Inter Tight" pitchFamily="34" charset="0"/>
                 <a:ea typeface="Inter Tight" pitchFamily="34" charset="-122"/>
@@ -1360,7 +1360,7 @@
             <a:r>
               <a:rPr lang="en-US" sz="2000" dirty="0">
                 <a:solidFill>
-                  <a:srgbClr val="4A4A4A"/>
+                  <a:srgbClr val="403B34"/>
                 </a:solidFill>
                 <a:latin typeface="Inter" pitchFamily="34" charset="0"/>
                 <a:ea typeface="Inter" pitchFamily="34" charset="-122"/>
@@ -1387,11 +1387,11 @@
             <a:avLst/>
           </a:prstGeom>
           <a:solidFill>
-            <a:srgbClr val="E8E3D0"/>
+            <a:srgbClr val="E8E4DA"/>
           </a:solidFill>
           <a:ln w="12700">
             <a:solidFill>
-              <a:srgbClr val="E8E3D0">
+              <a:srgbClr val="E8E4DA">
                 <a:alpha val="0"/>
               </a:srgbClr>
             </a:solidFill>
@@ -1426,7 +1426,7 @@
             <a:r>
               <a:rPr lang="en-US" sz="1200" dirty="0">
                 <a:solidFill>
-                  <a:srgbClr val="8A8A8A"/>
+                  <a:srgbClr val="8A8378"/>
                 </a:solidFill>
                 <a:latin typeface="Inter" pitchFamily="34" charset="0"/>
                 <a:ea typeface="Inter" pitchFamily="34" charset="-122"/>
@@ -1521,7 +1521,7 @@
             <a:r>
               <a:rPr lang="en-US" sz="1200" b="1" dirty="0">
                 <a:solidFill>
-                  <a:srgbClr val="FEFCF2"/>
+                  <a:srgbClr val="FDF5F5"/>
                 </a:solidFill>
                 <a:latin typeface="Inter Tight" pitchFamily="34" charset="0"/>
                 <a:ea typeface="Inter Tight" pitchFamily="34" charset="-122"/>
@@ -1560,7 +1560,7 @@
             <a:r>
               <a:rPr lang="en-US" sz="4400" b="1" dirty="0">
                 <a:solidFill>
-                  <a:srgbClr val="FEFCF2"/>
+                  <a:srgbClr val="FDF5F5"/>
                 </a:solidFill>
                 <a:latin typeface="Inter Tight" pitchFamily="34" charset="0"/>
                 <a:ea typeface="Inter Tight" pitchFamily="34" charset="-122"/>
@@ -1587,11 +1587,11 @@
             <a:avLst/>
           </a:prstGeom>
           <a:solidFill>
-            <a:srgbClr val="FEFCF2"/>
+            <a:srgbClr val="FDF5F5"/>
           </a:solidFill>
           <a:ln w="12700">
             <a:solidFill>
-              <a:srgbClr val="FEFCF2">
+              <a:srgbClr val="FDF5F5">
                 <a:alpha val="0"/>
               </a:srgbClr>
             </a:solidFill>
@@ -1613,7 +1613,7 @@
     <p:bg>
       <p:bgPr>
         <a:solidFill>
-          <a:srgbClr val="FEFCF2"/>
+          <a:srgbClr val="FDF5F5"/>
         </a:solidFill>
       </p:bgPr>
     </p:bg>
@@ -1697,7 +1697,7 @@
             <a:r>
               <a:rPr lang="en-US" sz="3600" b="1" dirty="0">
                 <a:solidFill>
-                  <a:srgbClr val="1A1A1A"/>
+                  <a:srgbClr val="15130F"/>
                 </a:solidFill>
                 <a:latin typeface="Inter Tight" pitchFamily="34" charset="0"/>
                 <a:ea typeface="Inter Tight" pitchFamily="34" charset="-122"/>
@@ -1724,11 +1724,11 @@
             <a:avLst/>
           </a:prstGeom>
           <a:solidFill>
-            <a:srgbClr val="E8E3D0"/>
+            <a:srgbClr val="E8E4DA"/>
           </a:solidFill>
           <a:ln w="12700">
             <a:solidFill>
-              <a:srgbClr val="E8E3D0">
+              <a:srgbClr val="E8E4DA">
                 <a:alpha val="0"/>
               </a:srgbClr>
             </a:solidFill>
@@ -1763,7 +1763,7 @@
             <a:r>
               <a:rPr lang="en-US" sz="3200" b="1" dirty="0">
                 <a:solidFill>
-                  <a:srgbClr val="1A1A1A"/>
+                  <a:srgbClr val="15130F"/>
                 </a:solidFill>
                 <a:latin typeface="Inter Tight" pitchFamily="34" charset="0"/>
                 <a:ea typeface="Inter Tight" pitchFamily="34" charset="-122"/>
@@ -1802,7 +1802,7 @@
             <a:r>
               <a:rPr lang="en-US" sz="2000" dirty="0">
                 <a:solidFill>
-                  <a:srgbClr val="4A4A4A"/>
+                  <a:srgbClr val="403B34"/>
                 </a:solidFill>
                 <a:latin typeface="Inter" pitchFamily="34" charset="0"/>
                 <a:ea typeface="Inter" pitchFamily="34" charset="-122"/>
@@ -1841,7 +1841,7 @@
             <a:r>
               <a:rPr lang="en-US" sz="2000" b="1" dirty="0">
                 <a:solidFill>
-                  <a:srgbClr val="1A1A1A"/>
+                  <a:srgbClr val="15130F"/>
                 </a:solidFill>
                 <a:latin typeface="Inter" pitchFamily="34" charset="0"/>
                 <a:ea typeface="Inter" pitchFamily="34" charset="-122"/>
@@ -1880,7 +1880,7 @@
             <a:r>
               <a:rPr lang="en-US" sz="2000" b="1" dirty="0">
                 <a:solidFill>
-                  <a:srgbClr val="1A1A1A"/>
+                  <a:srgbClr val="15130F"/>
                 </a:solidFill>
                 <a:latin typeface="Inter" pitchFamily="34" charset="0"/>
                 <a:ea typeface="Inter" pitchFamily="34" charset="-122"/>
@@ -1919,7 +1919,7 @@
             <a:r>
               <a:rPr lang="en-US" sz="2000" b="1" dirty="0">
                 <a:solidFill>
-                  <a:srgbClr val="1A1A1A"/>
+                  <a:srgbClr val="15130F"/>
                 </a:solidFill>
                 <a:latin typeface="Inter" pitchFamily="34" charset="0"/>
                 <a:ea typeface="Inter" pitchFamily="34" charset="-122"/>
@@ -2029,7 +2029,7 @@
             <a:r>
               <a:rPr lang="en-US" sz="3600" b="1" dirty="0">
                 <a:solidFill>
-                  <a:srgbClr val="1A1A1A"/>
+                  <a:srgbClr val="15130F"/>
                 </a:solidFill>
                 <a:latin typeface="Inter Tight" pitchFamily="34" charset="0"/>
                 <a:ea typeface="Inter Tight" pitchFamily="34" charset="-122"/>
@@ -2173,11 +2173,11 @@
             <a:avLst/>
           </a:prstGeom>
           <a:solidFill>
-            <a:srgbClr val="E8E8E8"/>
+            <a:srgbClr val="E8E4DA"/>
           </a:solidFill>
           <a:ln w="12700">
             <a:solidFill>
-              <a:srgbClr val="E8E8E8">
+              <a:srgbClr val="E8E4DA">
                 <a:alpha val="0"/>
               </a:srgbClr>
             </a:solidFill>
@@ -2212,7 +2212,7 @@
             <a:r>
               <a:rPr lang="en-US" sz="2000" b="1" dirty="0">
                 <a:solidFill>
-                  <a:srgbClr val="1A1A1A"/>
+                  <a:srgbClr val="15130F"/>
                 </a:solidFill>
                 <a:latin typeface="Inter" pitchFamily="34" charset="0"/>
                 <a:ea typeface="Inter" pitchFamily="34" charset="-122"/>
@@ -2251,7 +2251,7 @@
             <a:r>
               <a:rPr lang="en-US" sz="2000" dirty="0">
                 <a:solidFill>
-                  <a:srgbClr val="1A1A1A"/>
+                  <a:srgbClr val="15130F"/>
                 </a:solidFill>
                 <a:latin typeface="JetBrains Mono" pitchFamily="34" charset="0"/>
                 <a:ea typeface="JetBrains Mono" pitchFamily="34" charset="-122"/>
@@ -2290,7 +2290,7 @@
             <a:r>
               <a:rPr lang="en-US" sz="2000" dirty="0">
                 <a:solidFill>
-                  <a:srgbClr val="1A1A1A"/>
+                  <a:srgbClr val="15130F"/>
                 </a:solidFill>
                 <a:latin typeface="Inter" pitchFamily="34" charset="0"/>
                 <a:ea typeface="Inter" pitchFamily="34" charset="-122"/>
@@ -2317,11 +2317,11 @@
             <a:avLst/>
           </a:prstGeom>
           <a:solidFill>
-            <a:srgbClr val="E8E8E8"/>
+            <a:srgbClr val="E8E4DA"/>
           </a:solidFill>
           <a:ln w="12700">
             <a:solidFill>
-              <a:srgbClr val="E8E8E8">
+              <a:srgbClr val="E8E4DA">
                 <a:alpha val="0"/>
               </a:srgbClr>
             </a:solidFill>
@@ -2356,7 +2356,7 @@
             <a:r>
               <a:rPr lang="en-US" sz="2000" b="1" dirty="0">
                 <a:solidFill>
-                  <a:srgbClr val="1A1A1A"/>
+                  <a:srgbClr val="15130F"/>
                 </a:solidFill>
                 <a:latin typeface="Inter" pitchFamily="34" charset="0"/>
                 <a:ea typeface="Inter" pitchFamily="34" charset="-122"/>
@@ -2395,7 +2395,7 @@
             <a:r>
               <a:rPr lang="en-US" sz="2000" dirty="0">
                 <a:solidFill>
-                  <a:srgbClr val="1A1A1A"/>
+                  <a:srgbClr val="15130F"/>
                 </a:solidFill>
                 <a:latin typeface="JetBrains Mono" pitchFamily="34" charset="0"/>
                 <a:ea typeface="JetBrains Mono" pitchFamily="34" charset="-122"/>
@@ -2434,7 +2434,7 @@
             <a:r>
               <a:rPr lang="en-US" sz="2000" dirty="0">
                 <a:solidFill>
-                  <a:srgbClr val="1A1A1A"/>
+                  <a:srgbClr val="15130F"/>
                 </a:solidFill>
                 <a:latin typeface="Inter" pitchFamily="34" charset="0"/>
                 <a:ea typeface="Inter" pitchFamily="34" charset="-122"/>
@@ -2461,11 +2461,11 @@
             <a:avLst/>
           </a:prstGeom>
           <a:solidFill>
-            <a:srgbClr val="E8E8E8"/>
+            <a:srgbClr val="E8E4DA"/>
           </a:solidFill>
           <a:ln w="12700">
             <a:solidFill>
-              <a:srgbClr val="E8E8E8">
+              <a:srgbClr val="E8E4DA">
                 <a:alpha val="0"/>
               </a:srgbClr>
             </a:solidFill>
@@ -2500,7 +2500,7 @@
             <a:r>
               <a:rPr lang="en-US" sz="2000" b="1" dirty="0">
                 <a:solidFill>
-                  <a:srgbClr val="1A1A1A"/>
+                  <a:srgbClr val="15130F"/>
                 </a:solidFill>
                 <a:latin typeface="Inter" pitchFamily="34" charset="0"/>
                 <a:ea typeface="Inter" pitchFamily="34" charset="-122"/>
@@ -2539,7 +2539,7 @@
             <a:r>
               <a:rPr lang="en-US" sz="2000" dirty="0">
                 <a:solidFill>
-                  <a:srgbClr val="1A1A1A"/>
+                  <a:srgbClr val="15130F"/>
                 </a:solidFill>
                 <a:latin typeface="JetBrains Mono" pitchFamily="34" charset="0"/>
                 <a:ea typeface="JetBrains Mono" pitchFamily="34" charset="-122"/>
@@ -2578,7 +2578,7 @@
             <a:r>
               <a:rPr lang="en-US" sz="2000" dirty="0">
                 <a:solidFill>
-                  <a:srgbClr val="1A1A1A"/>
+                  <a:srgbClr val="15130F"/>
                 </a:solidFill>
                 <a:latin typeface="Inter" pitchFamily="34" charset="0"/>
                 <a:ea typeface="Inter" pitchFamily="34" charset="-122"/>
@@ -2605,11 +2605,11 @@
             <a:avLst/>
           </a:prstGeom>
           <a:solidFill>
-            <a:srgbClr val="E8E8E8"/>
+            <a:srgbClr val="E8E4DA"/>
           </a:solidFill>
           <a:ln w="12700">
             <a:solidFill>
-              <a:srgbClr val="E8E8E8">
+              <a:srgbClr val="E8E4DA">
                 <a:alpha val="0"/>
               </a:srgbClr>
             </a:solidFill>
@@ -2644,7 +2644,7 @@
             <a:r>
               <a:rPr lang="en-US" sz="1200" dirty="0">
                 <a:solidFill>
-                  <a:srgbClr val="8A8A8A"/>
+                  <a:srgbClr val="8A8378"/>
                 </a:solidFill>
                 <a:latin typeface="Inter" pitchFamily="34" charset="0"/>
                 <a:ea typeface="Inter" pitchFamily="34" charset="-122"/>
@@ -2670,7 +2670,7 @@
     <p:bg>
       <p:bgPr>
         <a:solidFill>
-          <a:srgbClr val="FEFCF2"/>
+          <a:srgbClr val="FDF5F5"/>
         </a:solidFill>
       </p:bgPr>
     </p:bg>
@@ -2766,11 +2766,11 @@
             <a:avLst/>
           </a:prstGeom>
           <a:solidFill>
-            <a:srgbClr val="E8E3D0"/>
+            <a:srgbClr val="E8E4DA"/>
           </a:solidFill>
           <a:ln w="12700">
             <a:solidFill>
-              <a:srgbClr val="E8E3D0">
+              <a:srgbClr val="E8E4DA">
                 <a:alpha val="0"/>
               </a:srgbClr>
             </a:solidFill>

</xml_diff>

<commit_message>
Apply the locked white-substrate palette and rationed red rules.
The approved handoff replaces cream paper with white, keeps cream for
callout bands, and limits red to 2px link, menu, and focus cues.

Co-authored-by: Cursor <cursoragent@cursor.com>
</commit_message>
<xml_diff>
--- a/brand/exports/agustos/office/agustos-template.pptx
+++ b/brand/exports/agustos/office/agustos-template.pptx
@@ -1213,7 +1213,7 @@
     <p:bg>
       <p:bgPr>
         <a:solidFill>
-          <a:srgbClr val="FEFCF2"/>
+          <a:srgbClr val="FDF5F5"/>
         </a:solidFill>
       </p:bgPr>
     </p:bg>
@@ -1321,7 +1321,7 @@
             <a:r>
               <a:rPr lang="en-US" sz="5400" b="1" dirty="0">
                 <a:solidFill>
-                  <a:srgbClr val="1A1A1A"/>
+                  <a:srgbClr val="15130F"/>
                 </a:solidFill>
                 <a:latin typeface="Inter Tight" pitchFamily="34" charset="0"/>
                 <a:ea typeface="Inter Tight" pitchFamily="34" charset="-122"/>
@@ -1360,7 +1360,7 @@
             <a:r>
               <a:rPr lang="en-US" sz="2000" dirty="0">
                 <a:solidFill>
-                  <a:srgbClr val="4A4A4A"/>
+                  <a:srgbClr val="403B34"/>
                 </a:solidFill>
                 <a:latin typeface="Inter" pitchFamily="34" charset="0"/>
                 <a:ea typeface="Inter" pitchFamily="34" charset="-122"/>
@@ -1387,11 +1387,11 @@
             <a:avLst/>
           </a:prstGeom>
           <a:solidFill>
-            <a:srgbClr val="E8E3D0"/>
+            <a:srgbClr val="E8E4DA"/>
           </a:solidFill>
           <a:ln w="12700">
             <a:solidFill>
-              <a:srgbClr val="E8E3D0">
+              <a:srgbClr val="E8E4DA">
                 <a:alpha val="0"/>
               </a:srgbClr>
             </a:solidFill>
@@ -1426,7 +1426,7 @@
             <a:r>
               <a:rPr lang="en-US" sz="1200" dirty="0">
                 <a:solidFill>
-                  <a:srgbClr val="8A8A8A"/>
+                  <a:srgbClr val="8A8378"/>
                 </a:solidFill>
                 <a:latin typeface="Inter" pitchFamily="34" charset="0"/>
                 <a:ea typeface="Inter" pitchFamily="34" charset="-122"/>
@@ -1521,7 +1521,7 @@
             <a:r>
               <a:rPr lang="en-US" sz="1200" b="1" dirty="0">
                 <a:solidFill>
-                  <a:srgbClr val="FEFCF2"/>
+                  <a:srgbClr val="FDF5F5"/>
                 </a:solidFill>
                 <a:latin typeface="Inter Tight" pitchFamily="34" charset="0"/>
                 <a:ea typeface="Inter Tight" pitchFamily="34" charset="-122"/>
@@ -1560,7 +1560,7 @@
             <a:r>
               <a:rPr lang="en-US" sz="4400" b="1" dirty="0">
                 <a:solidFill>
-                  <a:srgbClr val="FEFCF2"/>
+                  <a:srgbClr val="FDF5F5"/>
                 </a:solidFill>
                 <a:latin typeface="Inter Tight" pitchFamily="34" charset="0"/>
                 <a:ea typeface="Inter Tight" pitchFamily="34" charset="-122"/>
@@ -1587,11 +1587,11 @@
             <a:avLst/>
           </a:prstGeom>
           <a:solidFill>
-            <a:srgbClr val="FEFCF2"/>
+            <a:srgbClr val="FDF5F5"/>
           </a:solidFill>
           <a:ln w="12700">
             <a:solidFill>
-              <a:srgbClr val="FEFCF2">
+              <a:srgbClr val="FDF5F5">
                 <a:alpha val="0"/>
               </a:srgbClr>
             </a:solidFill>
@@ -1613,7 +1613,7 @@
     <p:bg>
       <p:bgPr>
         <a:solidFill>
-          <a:srgbClr val="FEFCF2"/>
+          <a:srgbClr val="FDF5F5"/>
         </a:solidFill>
       </p:bgPr>
     </p:bg>
@@ -1697,7 +1697,7 @@
             <a:r>
               <a:rPr lang="en-US" sz="3600" b="1" dirty="0">
                 <a:solidFill>
-                  <a:srgbClr val="1A1A1A"/>
+                  <a:srgbClr val="15130F"/>
                 </a:solidFill>
                 <a:latin typeface="Inter Tight" pitchFamily="34" charset="0"/>
                 <a:ea typeface="Inter Tight" pitchFamily="34" charset="-122"/>
@@ -1724,11 +1724,11 @@
             <a:avLst/>
           </a:prstGeom>
           <a:solidFill>
-            <a:srgbClr val="E8E3D0"/>
+            <a:srgbClr val="E8E4DA"/>
           </a:solidFill>
           <a:ln w="12700">
             <a:solidFill>
-              <a:srgbClr val="E8E3D0">
+              <a:srgbClr val="E8E4DA">
                 <a:alpha val="0"/>
               </a:srgbClr>
             </a:solidFill>
@@ -1763,7 +1763,7 @@
             <a:r>
               <a:rPr lang="en-US" sz="3200" b="1" dirty="0">
                 <a:solidFill>
-                  <a:srgbClr val="1A1A1A"/>
+                  <a:srgbClr val="15130F"/>
                 </a:solidFill>
                 <a:latin typeface="Inter Tight" pitchFamily="34" charset="0"/>
                 <a:ea typeface="Inter Tight" pitchFamily="34" charset="-122"/>
@@ -1802,7 +1802,7 @@
             <a:r>
               <a:rPr lang="en-US" sz="2000" dirty="0">
                 <a:solidFill>
-                  <a:srgbClr val="4A4A4A"/>
+                  <a:srgbClr val="403B34"/>
                 </a:solidFill>
                 <a:latin typeface="Inter" pitchFamily="34" charset="0"/>
                 <a:ea typeface="Inter" pitchFamily="34" charset="-122"/>
@@ -1841,7 +1841,7 @@
             <a:r>
               <a:rPr lang="en-US" sz="2000" b="1" dirty="0">
                 <a:solidFill>
-                  <a:srgbClr val="1A1A1A"/>
+                  <a:srgbClr val="15130F"/>
                 </a:solidFill>
                 <a:latin typeface="Inter" pitchFamily="34" charset="0"/>
                 <a:ea typeface="Inter" pitchFamily="34" charset="-122"/>
@@ -1880,7 +1880,7 @@
             <a:r>
               <a:rPr lang="en-US" sz="2000" b="1" dirty="0">
                 <a:solidFill>
-                  <a:srgbClr val="1A1A1A"/>
+                  <a:srgbClr val="15130F"/>
                 </a:solidFill>
                 <a:latin typeface="Inter" pitchFamily="34" charset="0"/>
                 <a:ea typeface="Inter" pitchFamily="34" charset="-122"/>
@@ -1919,7 +1919,7 @@
             <a:r>
               <a:rPr lang="en-US" sz="2000" b="1" dirty="0">
                 <a:solidFill>
-                  <a:srgbClr val="1A1A1A"/>
+                  <a:srgbClr val="15130F"/>
                 </a:solidFill>
                 <a:latin typeface="Inter" pitchFamily="34" charset="0"/>
                 <a:ea typeface="Inter" pitchFamily="34" charset="-122"/>
@@ -2029,7 +2029,7 @@
             <a:r>
               <a:rPr lang="en-US" sz="3600" b="1" dirty="0">
                 <a:solidFill>
-                  <a:srgbClr val="1A1A1A"/>
+                  <a:srgbClr val="15130F"/>
                 </a:solidFill>
                 <a:latin typeface="Inter Tight" pitchFamily="34" charset="0"/>
                 <a:ea typeface="Inter Tight" pitchFamily="34" charset="-122"/>
@@ -2173,11 +2173,11 @@
             <a:avLst/>
           </a:prstGeom>
           <a:solidFill>
-            <a:srgbClr val="E8E8E8"/>
+            <a:srgbClr val="E8E4DA"/>
           </a:solidFill>
           <a:ln w="12700">
             <a:solidFill>
-              <a:srgbClr val="E8E8E8">
+              <a:srgbClr val="E8E4DA">
                 <a:alpha val="0"/>
               </a:srgbClr>
             </a:solidFill>
@@ -2212,7 +2212,7 @@
             <a:r>
               <a:rPr lang="en-US" sz="2000" b="1" dirty="0">
                 <a:solidFill>
-                  <a:srgbClr val="1A1A1A"/>
+                  <a:srgbClr val="15130F"/>
                 </a:solidFill>
                 <a:latin typeface="Inter" pitchFamily="34" charset="0"/>
                 <a:ea typeface="Inter" pitchFamily="34" charset="-122"/>
@@ -2251,7 +2251,7 @@
             <a:r>
               <a:rPr lang="en-US" sz="2000" dirty="0">
                 <a:solidFill>
-                  <a:srgbClr val="1A1A1A"/>
+                  <a:srgbClr val="15130F"/>
                 </a:solidFill>
                 <a:latin typeface="JetBrains Mono" pitchFamily="34" charset="0"/>
                 <a:ea typeface="JetBrains Mono" pitchFamily="34" charset="-122"/>
@@ -2290,7 +2290,7 @@
             <a:r>
               <a:rPr lang="en-US" sz="2000" dirty="0">
                 <a:solidFill>
-                  <a:srgbClr val="1A1A1A"/>
+                  <a:srgbClr val="15130F"/>
                 </a:solidFill>
                 <a:latin typeface="Inter" pitchFamily="34" charset="0"/>
                 <a:ea typeface="Inter" pitchFamily="34" charset="-122"/>
@@ -2317,11 +2317,11 @@
             <a:avLst/>
           </a:prstGeom>
           <a:solidFill>
-            <a:srgbClr val="E8E8E8"/>
+            <a:srgbClr val="E8E4DA"/>
           </a:solidFill>
           <a:ln w="12700">
             <a:solidFill>
-              <a:srgbClr val="E8E8E8">
+              <a:srgbClr val="E8E4DA">
                 <a:alpha val="0"/>
               </a:srgbClr>
             </a:solidFill>
@@ -2356,7 +2356,7 @@
             <a:r>
               <a:rPr lang="en-US" sz="2000" b="1" dirty="0">
                 <a:solidFill>
-                  <a:srgbClr val="1A1A1A"/>
+                  <a:srgbClr val="15130F"/>
                 </a:solidFill>
                 <a:latin typeface="Inter" pitchFamily="34" charset="0"/>
                 <a:ea typeface="Inter" pitchFamily="34" charset="-122"/>
@@ -2395,7 +2395,7 @@
             <a:r>
               <a:rPr lang="en-US" sz="2000" dirty="0">
                 <a:solidFill>
-                  <a:srgbClr val="1A1A1A"/>
+                  <a:srgbClr val="15130F"/>
                 </a:solidFill>
                 <a:latin typeface="JetBrains Mono" pitchFamily="34" charset="0"/>
                 <a:ea typeface="JetBrains Mono" pitchFamily="34" charset="-122"/>
@@ -2434,7 +2434,7 @@
             <a:r>
               <a:rPr lang="en-US" sz="2000" dirty="0">
                 <a:solidFill>
-                  <a:srgbClr val="1A1A1A"/>
+                  <a:srgbClr val="15130F"/>
                 </a:solidFill>
                 <a:latin typeface="Inter" pitchFamily="34" charset="0"/>
                 <a:ea typeface="Inter" pitchFamily="34" charset="-122"/>
@@ -2461,11 +2461,11 @@
             <a:avLst/>
           </a:prstGeom>
           <a:solidFill>
-            <a:srgbClr val="E8E8E8"/>
+            <a:srgbClr val="E8E4DA"/>
           </a:solidFill>
           <a:ln w="12700">
             <a:solidFill>
-              <a:srgbClr val="E8E8E8">
+              <a:srgbClr val="E8E4DA">
                 <a:alpha val="0"/>
               </a:srgbClr>
             </a:solidFill>
@@ -2500,7 +2500,7 @@
             <a:r>
               <a:rPr lang="en-US" sz="2000" b="1" dirty="0">
                 <a:solidFill>
-                  <a:srgbClr val="1A1A1A"/>
+                  <a:srgbClr val="15130F"/>
                 </a:solidFill>
                 <a:latin typeface="Inter" pitchFamily="34" charset="0"/>
                 <a:ea typeface="Inter" pitchFamily="34" charset="-122"/>
@@ -2539,7 +2539,7 @@
             <a:r>
               <a:rPr lang="en-US" sz="2000" dirty="0">
                 <a:solidFill>
-                  <a:srgbClr val="1A1A1A"/>
+                  <a:srgbClr val="15130F"/>
                 </a:solidFill>
                 <a:latin typeface="JetBrains Mono" pitchFamily="34" charset="0"/>
                 <a:ea typeface="JetBrains Mono" pitchFamily="34" charset="-122"/>
@@ -2578,7 +2578,7 @@
             <a:r>
               <a:rPr lang="en-US" sz="2000" dirty="0">
                 <a:solidFill>
-                  <a:srgbClr val="1A1A1A"/>
+                  <a:srgbClr val="15130F"/>
                 </a:solidFill>
                 <a:latin typeface="Inter" pitchFamily="34" charset="0"/>
                 <a:ea typeface="Inter" pitchFamily="34" charset="-122"/>
@@ -2605,11 +2605,11 @@
             <a:avLst/>
           </a:prstGeom>
           <a:solidFill>
-            <a:srgbClr val="E8E8E8"/>
+            <a:srgbClr val="E8E4DA"/>
           </a:solidFill>
           <a:ln w="12700">
             <a:solidFill>
-              <a:srgbClr val="E8E8E8">
+              <a:srgbClr val="E8E4DA">
                 <a:alpha val="0"/>
               </a:srgbClr>
             </a:solidFill>
@@ -2644,7 +2644,7 @@
             <a:r>
               <a:rPr lang="en-US" sz="1200" dirty="0">
                 <a:solidFill>
-                  <a:srgbClr val="8A8A8A"/>
+                  <a:srgbClr val="8A8378"/>
                 </a:solidFill>
                 <a:latin typeface="Inter" pitchFamily="34" charset="0"/>
                 <a:ea typeface="Inter" pitchFamily="34" charset="-122"/>
@@ -2670,7 +2670,7 @@
     <p:bg>
       <p:bgPr>
         <a:solidFill>
-          <a:srgbClr val="FEFCF2"/>
+          <a:srgbClr val="FDF5F5"/>
         </a:solidFill>
       </p:bgPr>
     </p:bg>
@@ -2766,11 +2766,11 @@
             <a:avLst/>
           </a:prstGeom>
           <a:solidFill>
-            <a:srgbClr val="E8E3D0"/>
+            <a:srgbClr val="E8E4DA"/>
           </a:solidFill>
           <a:ln w="12700">
             <a:solidFill>
-              <a:srgbClr val="E8E3D0">
+              <a:srgbClr val="E8E4DA">
                 <a:alpha val="0"/>
               </a:srgbClr>
             </a:solidFill>

</xml_diff>

<commit_message>
Lock the six-colour palette and dark theme for v5.0.0.
Replace the first white-substrate greys with #ebebeb and #404040, and flip the same six roles for dark instead of keeping the old invert.

Co-authored-by: Cursor <cursoragent@cursor.com>
</commit_message>
<xml_diff>
--- a/brand/exports/agustos/office/agustos-template.pptx
+++ b/brand/exports/agustos/office/agustos-template.pptx
@@ -1360,7 +1360,7 @@
             <a:r>
               <a:rPr lang="en-US" sz="2000" dirty="0">
                 <a:solidFill>
-                  <a:srgbClr val="403B34"/>
+                  <a:srgbClr val="404040"/>
                 </a:solidFill>
                 <a:latin typeface="Inter" pitchFamily="34" charset="0"/>
                 <a:ea typeface="Inter" pitchFamily="34" charset="-122"/>
@@ -1802,7 +1802,7 @@
             <a:r>
               <a:rPr lang="en-US" sz="2000" dirty="0">
                 <a:solidFill>
-                  <a:srgbClr val="403B34"/>
+                  <a:srgbClr val="404040"/>
                 </a:solidFill>
                 <a:latin typeface="Inter" pitchFamily="34" charset="0"/>
                 <a:ea typeface="Inter" pitchFamily="34" charset="-122"/>

</xml_diff>